<commit_message>
Corum pitch: ronde 2 herzien - 'deliver the works, PwC fully aware & aligned'; copy afgestemd op samenvattingsmail aan Corum
Co-Authored-By: Claude Opus 4.8 <noreply@anthropic.com>
Claude-Session: https://claude.ai/code/session_01Ve1ndCHgviaGx4xoosLGch
</commit_message>
<xml_diff>
--- a/corum-pitch/Corum-Westgate-I-Pitch-Wireframe.pptx
+++ b/corum-pitch/Corum-Westgate-I-Pitch-Wireframe.pptx
@@ -3302,7 +3302,7 @@
                 </a:solidFill>
                 <a:latin typeface="Arial"/>
               </a:rPr>
-              <a:t>Your single point of control for the sustainable transformation of a live, PwC-occupied asset</a:t>
+              <a:t>Your single point of control — delivering Paris Proof with tenant PwC fully aware and aligned</a:t>
             </a:r>
           </a:p>
         </p:txBody>
@@ -3551,7 +3551,7 @@
                 </a:solidFill>
                 <a:latin typeface="Arial"/>
               </a:rPr>
-              <a:t>We manage PwC for you — so your tenant stays confident</a:t>
+              <a:t>We deliver the works with PwC fully aware and aligned —</a:t>
             </a:r>
           </a:p>
           <a:p>
@@ -3563,7 +3563,7 @@
                 </a:solidFill>
                 <a:latin typeface="Arial"/>
               </a:rPr>
-              <a:t>and your lease stays intact</a:t>
+              <a:t>so your tenant stays confident and your lease stays intact</a:t>
             </a:r>
           </a:p>
         </p:txBody>
@@ -3747,7 +3747,7 @@
                 </a:solidFill>
                 <a:latin typeface="Arial"/>
               </a:rPr>
-              <a:t>From day one, PwC deals with one familiar C&amp;W face, not with Corum and not with a rotating cast of contractors. We absorb the friction of a live rebuild so that the tenant experiences a landlord who is organised, transparent and in control. This is how a construction programme protects — rather than erodes — the value of the tenancy.</a:t>
+              <a:t>From day one, PwC deals with one familiar C&amp;W face. We keep the tenant actively involved in the decisions that affect them, with continuous insight into progress and planning and timely notice of anything that touches their operations. The outcome, in Corum's own words: PwC experiences full confidence that the project is under control.</a:t>
             </a:r>
           </a:p>
         </p:txBody>
@@ -3829,7 +3829,7 @@
                 </a:solidFill>
                 <a:latin typeface="Arial"/>
               </a:rPr>
-              <a:t>SINGLE TENANT INTERFACE</a:t>
+              <a:t>ONE FAMILIAR INTERFACE</a:t>
             </a:r>
           </a:p>
         </p:txBody>
@@ -3864,7 +3864,7 @@
                 </a:solidFill>
                 <a:latin typeface="Arial"/>
               </a:rPr>
-              <a:t>One dedicated Stakeholder Management PM owns the PwC relationship end-to-end: the single, consistent point of contact for everything that touches the tenant.</a:t>
+              <a:t>The Stakeholder Management PM owns the PwC relationship end-to-end — one consistent, familiar point of contact for everything that touches the tenant.</a:t>
             </a:r>
           </a:p>
         </p:txBody>
@@ -3946,7 +3946,7 @@
                 </a:solidFill>
                 <a:latin typeface="Arial"/>
               </a:rPr>
-              <a:t>EXPECTATION MANAGEMENT</a:t>
+              <a:t>ACTIVELY INVOLVED IN DECISIONS</a:t>
             </a:r>
           </a:p>
         </p:txBody>
@@ -3981,7 +3981,7 @@
                 </a:solidFill>
                 <a:latin typeface="Arial"/>
               </a:rPr>
-              <a:t>A tenant communication plan agreed up front: what happens, when, on which floor, and how we keep noise, dust and disruption inside agreed windows.</a:t>
+              <a:t>PwC is actively involved in the decision-making process on matters that affect them — briefed early, aligned before we act, never presented with a fait accompli.</a:t>
             </a:r>
           </a:p>
         </p:txBody>
@@ -4063,7 +4063,7 @@
                 </a:solidFill>
                 <a:latin typeface="Arial"/>
               </a:rPr>
-              <a:t>DECISIONS PREPARED WITH PwC</a:t>
+              <a:t>CONTINUOUS INSIGHT &amp; TIMELY NOTICE</a:t>
             </a:r>
           </a:p>
         </p:txBody>
@@ -4098,7 +4098,7 @@
                 </a:solidFill>
                 <a:latin typeface="Arial"/>
               </a:rPr>
-              <a:t>PwC is actively involved in decisions that affect them — briefed early, never surprised — so impact on their operations is designed out before it occurs.</a:t>
+              <a:t>Continuous insight into progress and planning, and timely communication of any change that impacts business operations — noise, access and disruption kept inside agreed windows.</a:t>
             </a:r>
           </a:p>
         </p:txBody>
@@ -4180,7 +4180,7 @@
                 </a:solidFill>
                 <a:latin typeface="Arial"/>
               </a:rPr>
-              <a:t>PROTECTING THE ASSET VALUE</a:t>
+              <a:t>FULL CONFIDENCE, PROTECTED VALUE</a:t>
             </a:r>
           </a:p>
         </p:txBody>
@@ -4215,7 +4215,7 @@
                 </a:solidFill>
                 <a:latin typeface="Arial"/>
               </a:rPr>
-              <a:t>A satisfied tenant renews. By managing PwC professionally through the works, we protect lease retention and, with it, the income and exit value of the asset for Corum.</a:t>
+              <a:t>The outcome Corum asked for: PwC experiences full confidence that the project is under control. A confident tenant renews — protecting lease retention, income and exit value.</a:t>
             </a:r>
           </a:p>
         </p:txBody>
@@ -19883,7 +19883,7 @@
                 </a:solidFill>
                 <a:latin typeface="Arial"/>
               </a:rPr>
-              <a:t>Appoint C&amp;W as your single point of control: we manage PwC and</a:t>
+              <a:t>Appoint C&amp;W as your single point of control: we deliver Paris Proof</a:t>
             </a:r>
           </a:p>
           <a:p>
@@ -19895,7 +19895,7 @@
                 </a:solidFill>
                 <a:latin typeface="Arial"/>
               </a:rPr>
-              <a:t>organize Paris Proof, so you decide and we deliver</a:t>
+              <a:t>with PwC fully aware and aligned — you decide, we deliver</a:t>
             </a:r>
           </a:p>
         </p:txBody>
@@ -20696,7 +20696,7 @@
                 </a:solidFill>
                 <a:latin typeface="Arial"/>
               </a:rPr>
-              <a:t>Appoint Cushman &amp; Wakefield as your single point of control. We manage PwC on your behalf and orchestrate the entire sustainability transformation end-to-end — from a low-commitment preparatory phase to Paris Proof handover. One contact, one report, no surprises.</a:t>
+              <a:t>Appoint Cushman &amp; Wakefield as your single point of control. We deliver the Paris Proof transformation end-to-end and keep PwC fully aware and aligned throughout — from a low-commitment preparatory phase to verified handover. One contact, one report, no surprises.</a:t>
             </a:r>
           </a:p>
         </p:txBody>
@@ -28687,7 +28687,7 @@
                 </a:solidFill>
                 <a:latin typeface="Arial"/>
               </a:rPr>
-              <a:t>We manage PwC on your behalf, and we organize the entire Paris Proof transformation end-to-end. You steer the asset; we run the building, the tenant and the works — and we bring you every decision, prepared, before it is needed.</a:t>
+              <a:t>We deliver the entire Paris Proof transformation end-to-end and keep PwC fully aware and aligned at every step. You steer the asset; we run the works and the tenant relationship — and we bring you every decision, prepared, before it is needed.</a:t>
             </a:r>
           </a:p>
         </p:txBody>
@@ -29175,7 +29175,7 @@
                 </a:solidFill>
                 <a:latin typeface="Arial"/>
               </a:rPr>
-              <a:t>WE MANAGE PwC</a:t>
+              <a:t>PwC FULLY AWARE</a:t>
             </a:r>
           </a:p>
           <a:p>
@@ -29187,7 +29187,7 @@
                 </a:solidFill>
                 <a:latin typeface="Arial"/>
               </a:rPr>
-              <a:t>FOR YOU</a:t>
+              <a:t>&amp; ALIGNED</a:t>
             </a:r>
           </a:p>
         </p:txBody>
@@ -29226,7 +29226,7 @@
                 </a:solidFill>
                 <a:latin typeface="Arial"/>
               </a:rPr>
-              <a:t>•  Single point of contact for the tenant</a:t>
+              <a:t>•  One familiar point of contact for PwC</a:t>
             </a:r>
           </a:p>
           <a:p>
@@ -29242,7 +29242,7 @@
                 </a:solidFill>
                 <a:latin typeface="Arial"/>
               </a:rPr>
-              <a:t>•  Manage expectations &amp; communication</a:t>
+              <a:t>•  PwC actively involved in decisions that affect them</a:t>
             </a:r>
           </a:p>
           <a:p>
@@ -29258,7 +29258,7 @@
                 </a:solidFill>
                 <a:latin typeface="Arial"/>
               </a:rPr>
-              <a:t>•  Minimise disruption to PwC operations</a:t>
+              <a:t>•  Continuous insight into progress &amp; planning</a:t>
             </a:r>
           </a:p>
           <a:p>
@@ -29274,7 +29274,7 @@
                 </a:solidFill>
                 <a:latin typeface="Arial"/>
               </a:rPr>
-              <a:t>•  Protect the lease and the relationship</a:t>
+              <a:t>•  Timely notice of anything impacting operations</a:t>
             </a:r>
           </a:p>
           <a:p>
@@ -29290,7 +29290,7 @@
                 </a:solidFill>
                 <a:latin typeface="Arial"/>
               </a:rPr>
-              <a:t>•  Shield Corum from day-to-day tenant issues</a:t>
+              <a:t>•  PwC feels the project is fully under control</a:t>
             </a:r>
           </a:p>
         </p:txBody>
@@ -29811,7 +29811,7 @@
                 </a:solidFill>
                 <a:latin typeface="Arial"/>
               </a:rPr>
-              <a:t>Corum keeps the decisions that matter. Everything else — the tenant, the contractor, the site, the paperwork — sits with us.</a:t>
+              <a:t>Corum keeps the decisions that matter. We deliver the works and keep PwC fully aware and aligned — so nothing ever lands on Corum by surprise.</a:t>
             </a:r>
           </a:p>
         </p:txBody>

</xml_diff>

<commit_message>
Corum pitch: golden thread uitgebreid naar CORUM DECIDES - C&W DELIVERS - PwC ALIGNED; twee losse prompts (Fabel 5 + Claude Design)
Co-Authored-By: Claude Opus 4.8 <noreply@anthropic.com>
Claude-Session: https://claude.ai/code/session_01Ve1ndCHgviaGx4xoosLGch
</commit_message>
<xml_diff>
--- a/corum-pitch/Corum-Westgate-I-Pitch-Wireframe.pptx
+++ b/corum-pitch/Corum-Westgate-I-Pitch-Wireframe.pptx
@@ -3646,8 +3646,8 @@
         </p:nvSpPr>
         <p:spPr>
           <a:xfrm>
-            <a:off x="8915400" y="6419088"/>
-            <a:ext cx="2514600" cy="292608"/>
+            <a:off x="7726679" y="6419088"/>
+            <a:ext cx="3657600" cy="292608"/>
           </a:xfrm>
           <a:prstGeom prst="roundRect">
             <a:avLst/>
@@ -3690,8 +3690,8 @@
         </p:nvSpPr>
         <p:spPr>
           <a:xfrm>
-            <a:off x="8915400" y="6446520"/>
-            <a:ext cx="2514600" cy="256032"/>
+            <a:off x="7726679" y="6455664"/>
+            <a:ext cx="3657600" cy="237744"/>
           </a:xfrm>
           <a:prstGeom prst="rect">
             <a:avLst/>
@@ -3712,7 +3712,7 @@
                 </a:solidFill>
                 <a:latin typeface="Arial"/>
               </a:rPr>
-              <a:t>CORUM DECIDES  ·  C&amp;W DELIVERS</a:t>
+              <a:t>CORUM DECIDES  ·  C&amp;W DELIVERS  ·  PwC ALIGNED</a:t>
             </a:r>
           </a:p>
         </p:txBody>
@@ -4442,8 +4442,8 @@
         </p:nvSpPr>
         <p:spPr>
           <a:xfrm>
-            <a:off x="8915400" y="6419088"/>
-            <a:ext cx="2514600" cy="292608"/>
+            <a:off x="7726679" y="6419088"/>
+            <a:ext cx="3657600" cy="292608"/>
           </a:xfrm>
           <a:prstGeom prst="roundRect">
             <a:avLst/>
@@ -4486,8 +4486,8 @@
         </p:nvSpPr>
         <p:spPr>
           <a:xfrm>
-            <a:off x="8915400" y="6446520"/>
-            <a:ext cx="2514600" cy="256032"/>
+            <a:off x="7726679" y="6455664"/>
+            <a:ext cx="3657600" cy="237744"/>
           </a:xfrm>
           <a:prstGeom prst="rect">
             <a:avLst/>
@@ -4508,7 +4508,7 @@
                 </a:solidFill>
                 <a:latin typeface="Arial"/>
               </a:rPr>
-              <a:t>CORUM DECIDES  ·  C&amp;W DELIVERS</a:t>
+              <a:t>CORUM DECIDES  ·  C&amp;W DELIVERS  ·  PwC ALIGNED</a:t>
             </a:r>
           </a:p>
         </p:txBody>
@@ -5784,8 +5784,8 @@
         </p:nvSpPr>
         <p:spPr>
           <a:xfrm>
-            <a:off x="8915400" y="6419088"/>
-            <a:ext cx="2514600" cy="292608"/>
+            <a:off x="7726679" y="6419088"/>
+            <a:ext cx="3657600" cy="292608"/>
           </a:xfrm>
           <a:prstGeom prst="roundRect">
             <a:avLst/>
@@ -5828,8 +5828,8 @@
         </p:nvSpPr>
         <p:spPr>
           <a:xfrm>
-            <a:off x="8915400" y="6446520"/>
-            <a:ext cx="2514600" cy="256032"/>
+            <a:off x="7726679" y="6455664"/>
+            <a:ext cx="3657600" cy="237744"/>
           </a:xfrm>
           <a:prstGeom prst="rect">
             <a:avLst/>
@@ -5850,7 +5850,7 @@
                 </a:solidFill>
                 <a:latin typeface="Arial"/>
               </a:rPr>
-              <a:t>CORUM DECIDES  ·  C&amp;W DELIVERS</a:t>
+              <a:t>CORUM DECIDES  ·  C&amp;W DELIVERS  ·  PwC ALIGNED</a:t>
             </a:r>
           </a:p>
         </p:txBody>
@@ -6545,8 +6545,8 @@
         </p:nvSpPr>
         <p:spPr>
           <a:xfrm>
-            <a:off x="8915400" y="6419088"/>
-            <a:ext cx="2514600" cy="292608"/>
+            <a:off x="7726679" y="6419088"/>
+            <a:ext cx="3657600" cy="292608"/>
           </a:xfrm>
           <a:prstGeom prst="roundRect">
             <a:avLst/>
@@ -6589,8 +6589,8 @@
         </p:nvSpPr>
         <p:spPr>
           <a:xfrm>
-            <a:off x="8915400" y="6446520"/>
-            <a:ext cx="2514600" cy="256032"/>
+            <a:off x="7726679" y="6455664"/>
+            <a:ext cx="3657600" cy="237744"/>
           </a:xfrm>
           <a:prstGeom prst="rect">
             <a:avLst/>
@@ -6611,7 +6611,7 @@
                 </a:solidFill>
                 <a:latin typeface="Arial"/>
               </a:rPr>
-              <a:t>CORUM DECIDES  ·  C&amp;W DELIVERS</a:t>
+              <a:t>CORUM DECIDES  ·  C&amp;W DELIVERS  ·  PwC ALIGNED</a:t>
             </a:r>
           </a:p>
         </p:txBody>
@@ -7811,8 +7811,8 @@
         </p:nvSpPr>
         <p:spPr>
           <a:xfrm>
-            <a:off x="8915400" y="6419088"/>
-            <a:ext cx="2514600" cy="292608"/>
+            <a:off x="7726679" y="6419088"/>
+            <a:ext cx="3657600" cy="292608"/>
           </a:xfrm>
           <a:prstGeom prst="roundRect">
             <a:avLst/>
@@ -7855,8 +7855,8 @@
         </p:nvSpPr>
         <p:spPr>
           <a:xfrm>
-            <a:off x="8915400" y="6446520"/>
-            <a:ext cx="2514600" cy="256032"/>
+            <a:off x="7726679" y="6455664"/>
+            <a:ext cx="3657600" cy="237744"/>
           </a:xfrm>
           <a:prstGeom prst="rect">
             <a:avLst/>
@@ -7877,7 +7877,7 @@
                 </a:solidFill>
                 <a:latin typeface="Arial"/>
               </a:rPr>
-              <a:t>CORUM DECIDES  ·  C&amp;W DELIVERS</a:t>
+              <a:t>CORUM DECIDES  ·  C&amp;W DELIVERS  ·  PwC ALIGNED</a:t>
             </a:r>
           </a:p>
         </p:txBody>
@@ -9098,8 +9098,8 @@
         </p:nvSpPr>
         <p:spPr>
           <a:xfrm>
-            <a:off x="8915400" y="6419088"/>
-            <a:ext cx="2514600" cy="292608"/>
+            <a:off x="7726679" y="6419088"/>
+            <a:ext cx="3657600" cy="292608"/>
           </a:xfrm>
           <a:prstGeom prst="roundRect">
             <a:avLst/>
@@ -9142,8 +9142,8 @@
         </p:nvSpPr>
         <p:spPr>
           <a:xfrm>
-            <a:off x="8915400" y="6446520"/>
-            <a:ext cx="2514600" cy="256032"/>
+            <a:off x="7726679" y="6455664"/>
+            <a:ext cx="3657600" cy="237744"/>
           </a:xfrm>
           <a:prstGeom prst="rect">
             <a:avLst/>
@@ -9164,7 +9164,7 @@
                 </a:solidFill>
                 <a:latin typeface="Arial"/>
               </a:rPr>
-              <a:t>CORUM DECIDES  ·  C&amp;W DELIVERS</a:t>
+              <a:t>CORUM DECIDES  ·  C&amp;W DELIVERS  ·  PwC ALIGNED</a:t>
             </a:r>
           </a:p>
         </p:txBody>
@@ -10499,8 +10499,8 @@
         </p:nvSpPr>
         <p:spPr>
           <a:xfrm>
-            <a:off x="8915400" y="6419088"/>
-            <a:ext cx="2514600" cy="292608"/>
+            <a:off x="7726679" y="6419088"/>
+            <a:ext cx="3657600" cy="292608"/>
           </a:xfrm>
           <a:prstGeom prst="roundRect">
             <a:avLst/>
@@ -10543,8 +10543,8 @@
         </p:nvSpPr>
         <p:spPr>
           <a:xfrm>
-            <a:off x="8915400" y="6446520"/>
-            <a:ext cx="2514600" cy="256032"/>
+            <a:off x="7726679" y="6455664"/>
+            <a:ext cx="3657600" cy="237744"/>
           </a:xfrm>
           <a:prstGeom prst="rect">
             <a:avLst/>
@@ -10565,7 +10565,7 @@
                 </a:solidFill>
                 <a:latin typeface="Arial"/>
               </a:rPr>
-              <a:t>CORUM DECIDES  ·  C&amp;W DELIVERS</a:t>
+              <a:t>CORUM DECIDES  ·  C&amp;W DELIVERS  ·  PwC ALIGNED</a:t>
             </a:r>
           </a:p>
         </p:txBody>
@@ -11503,8 +11503,8 @@
         </p:nvSpPr>
         <p:spPr>
           <a:xfrm>
-            <a:off x="8915400" y="6419088"/>
-            <a:ext cx="2514600" cy="292608"/>
+            <a:off x="7726679" y="6419088"/>
+            <a:ext cx="3657600" cy="292608"/>
           </a:xfrm>
           <a:prstGeom prst="roundRect">
             <a:avLst/>
@@ -11547,8 +11547,8 @@
         </p:nvSpPr>
         <p:spPr>
           <a:xfrm>
-            <a:off x="8915400" y="6446520"/>
-            <a:ext cx="2514600" cy="256032"/>
+            <a:off x="7726679" y="6455664"/>
+            <a:ext cx="3657600" cy="237744"/>
           </a:xfrm>
           <a:prstGeom prst="rect">
             <a:avLst/>
@@ -11569,7 +11569,7 @@
                 </a:solidFill>
                 <a:latin typeface="Arial"/>
               </a:rPr>
-              <a:t>CORUM DECIDES  ·  C&amp;W DELIVERS</a:t>
+              <a:t>CORUM DECIDES  ·  C&amp;W DELIVERS  ·  PwC ALIGNED</a:t>
             </a:r>
           </a:p>
         </p:txBody>
@@ -14719,8 +14719,8 @@
         </p:nvSpPr>
         <p:spPr>
           <a:xfrm>
-            <a:off x="8915400" y="6419088"/>
-            <a:ext cx="2514600" cy="292608"/>
+            <a:off x="7726679" y="6419088"/>
+            <a:ext cx="3657600" cy="292608"/>
           </a:xfrm>
           <a:prstGeom prst="roundRect">
             <a:avLst/>
@@ -14763,8 +14763,8 @@
         </p:nvSpPr>
         <p:spPr>
           <a:xfrm>
-            <a:off x="8915400" y="6446520"/>
-            <a:ext cx="2514600" cy="256032"/>
+            <a:off x="7726679" y="6455664"/>
+            <a:ext cx="3657600" cy="237744"/>
           </a:xfrm>
           <a:prstGeom prst="rect">
             <a:avLst/>
@@ -14785,7 +14785,7 @@
                 </a:solidFill>
                 <a:latin typeface="Arial"/>
               </a:rPr>
-              <a:t>CORUM DECIDES  ·  C&amp;W DELIVERS</a:t>
+              <a:t>CORUM DECIDES  ·  C&amp;W DELIVERS  ·  PwC ALIGNED</a:t>
             </a:r>
           </a:p>
         </p:txBody>
@@ -16177,8 +16177,8 @@
         </p:nvSpPr>
         <p:spPr>
           <a:xfrm>
-            <a:off x="8915400" y="6419088"/>
-            <a:ext cx="2514600" cy="292608"/>
+            <a:off x="7726679" y="6419088"/>
+            <a:ext cx="3657600" cy="292608"/>
           </a:xfrm>
           <a:prstGeom prst="roundRect">
             <a:avLst/>
@@ -16221,8 +16221,8 @@
         </p:nvSpPr>
         <p:spPr>
           <a:xfrm>
-            <a:off x="8915400" y="6446520"/>
-            <a:ext cx="2514600" cy="256032"/>
+            <a:off x="7726679" y="6455664"/>
+            <a:ext cx="3657600" cy="237744"/>
           </a:xfrm>
           <a:prstGeom prst="rect">
             <a:avLst/>
@@ -16243,7 +16243,7 @@
                 </a:solidFill>
                 <a:latin typeface="Arial"/>
               </a:rPr>
-              <a:t>CORUM DECIDES  ·  C&amp;W DELIVERS</a:t>
+              <a:t>CORUM DECIDES  ·  C&amp;W DELIVERS  ·  PwC ALIGNED</a:t>
             </a:r>
           </a:p>
         </p:txBody>
@@ -19978,8 +19978,8 @@
         </p:nvSpPr>
         <p:spPr>
           <a:xfrm>
-            <a:off x="8915400" y="6419088"/>
-            <a:ext cx="2514600" cy="292608"/>
+            <a:off x="7726679" y="6419088"/>
+            <a:ext cx="3657600" cy="292608"/>
           </a:xfrm>
           <a:prstGeom prst="roundRect">
             <a:avLst/>
@@ -20022,8 +20022,8 @@
         </p:nvSpPr>
         <p:spPr>
           <a:xfrm>
-            <a:off x="8915400" y="6446520"/>
-            <a:ext cx="2514600" cy="256032"/>
+            <a:off x="7726679" y="6455664"/>
+            <a:ext cx="3657600" cy="237744"/>
           </a:xfrm>
           <a:prstGeom prst="rect">
             <a:avLst/>
@@ -20044,7 +20044,7 @@
                 </a:solidFill>
                 <a:latin typeface="Arial"/>
               </a:rPr>
-              <a:t>CORUM DECIDES  ·  C&amp;W DELIVERS</a:t>
+              <a:t>CORUM DECIDES  ·  C&amp;W DELIVERS  ·  PwC ALIGNED</a:t>
             </a:r>
           </a:p>
         </p:txBody>
@@ -20911,8 +20911,8 @@
         </p:nvSpPr>
         <p:spPr>
           <a:xfrm>
-            <a:off x="8915400" y="6419088"/>
-            <a:ext cx="2514600" cy="292608"/>
+            <a:off x="7726679" y="6419088"/>
+            <a:ext cx="3657600" cy="292608"/>
           </a:xfrm>
           <a:prstGeom prst="roundRect">
             <a:avLst/>
@@ -20955,8 +20955,8 @@
         </p:nvSpPr>
         <p:spPr>
           <a:xfrm>
-            <a:off x="8915400" y="6446520"/>
-            <a:ext cx="2514600" cy="256032"/>
+            <a:off x="7726679" y="6455664"/>
+            <a:ext cx="3657600" cy="237744"/>
           </a:xfrm>
           <a:prstGeom prst="rect">
             <a:avLst/>
@@ -20977,7 +20977,7 @@
                 </a:solidFill>
                 <a:latin typeface="Arial"/>
               </a:rPr>
-              <a:t>CORUM DECIDES  ·  C&amp;W DELIVERS</a:t>
+              <a:t>CORUM DECIDES  ·  C&amp;W DELIVERS  ·  PwC ALIGNED</a:t>
             </a:r>
           </a:p>
         </p:txBody>
@@ -21795,8 +21795,8 @@
         </p:nvSpPr>
         <p:spPr>
           <a:xfrm>
-            <a:off x="8915400" y="6419088"/>
-            <a:ext cx="2514600" cy="292608"/>
+            <a:off x="7726679" y="6419088"/>
+            <a:ext cx="3657600" cy="292608"/>
           </a:xfrm>
           <a:prstGeom prst="roundRect">
             <a:avLst/>
@@ -21839,8 +21839,8 @@
         </p:nvSpPr>
         <p:spPr>
           <a:xfrm>
-            <a:off x="8915400" y="6446520"/>
-            <a:ext cx="2514600" cy="256032"/>
+            <a:off x="7726679" y="6455664"/>
+            <a:ext cx="3657600" cy="237744"/>
           </a:xfrm>
           <a:prstGeom prst="rect">
             <a:avLst/>
@@ -21861,7 +21861,7 @@
                 </a:solidFill>
                 <a:latin typeface="Arial"/>
               </a:rPr>
-              <a:t>CORUM DECIDES  ·  C&amp;W DELIVERS</a:t>
+              <a:t>CORUM DECIDES  ·  C&amp;W DELIVERS  ·  PwC ALIGNED</a:t>
             </a:r>
           </a:p>
         </p:txBody>
@@ -23063,8 +23063,8 @@
         </p:nvSpPr>
         <p:spPr>
           <a:xfrm>
-            <a:off x="8915400" y="6419088"/>
-            <a:ext cx="2514600" cy="292608"/>
+            <a:off x="7726679" y="6419088"/>
+            <a:ext cx="3657600" cy="292608"/>
           </a:xfrm>
           <a:prstGeom prst="roundRect">
             <a:avLst/>
@@ -23107,8 +23107,8 @@
         </p:nvSpPr>
         <p:spPr>
           <a:xfrm>
-            <a:off x="8915400" y="6446520"/>
-            <a:ext cx="2514600" cy="256032"/>
+            <a:off x="7726679" y="6455664"/>
+            <a:ext cx="3657600" cy="237744"/>
           </a:xfrm>
           <a:prstGeom prst="rect">
             <a:avLst/>
@@ -23129,7 +23129,7 @@
                 </a:solidFill>
                 <a:latin typeface="Arial"/>
               </a:rPr>
-              <a:t>CORUM DECIDES  ·  C&amp;W DELIVERS</a:t>
+              <a:t>CORUM DECIDES  ·  C&amp;W DELIVERS  ·  PwC ALIGNED</a:t>
             </a:r>
           </a:p>
         </p:txBody>
@@ -26652,8 +26652,8 @@
         </p:nvSpPr>
         <p:spPr>
           <a:xfrm>
-            <a:off x="8915400" y="6419088"/>
-            <a:ext cx="2514600" cy="292608"/>
+            <a:off x="7726679" y="6419088"/>
+            <a:ext cx="3657600" cy="292608"/>
           </a:xfrm>
           <a:prstGeom prst="roundRect">
             <a:avLst/>
@@ -26696,8 +26696,8 @@
         </p:nvSpPr>
         <p:spPr>
           <a:xfrm>
-            <a:off x="8915400" y="6446520"/>
-            <a:ext cx="2514600" cy="256032"/>
+            <a:off x="7726679" y="6455664"/>
+            <a:ext cx="3657600" cy="237744"/>
           </a:xfrm>
           <a:prstGeom prst="rect">
             <a:avLst/>
@@ -26718,7 +26718,7 @@
                 </a:solidFill>
                 <a:latin typeface="Arial"/>
               </a:rPr>
-              <a:t>CORUM DECIDES  ·  C&amp;W DELIVERS</a:t>
+              <a:t>CORUM DECIDES  ·  C&amp;W DELIVERS  ·  PwC ALIGNED</a:t>
             </a:r>
           </a:p>
         </p:txBody>
@@ -27662,8 +27662,8 @@
         </p:nvSpPr>
         <p:spPr>
           <a:xfrm>
-            <a:off x="8915400" y="6419088"/>
-            <a:ext cx="2514600" cy="292608"/>
+            <a:off x="7726679" y="6419088"/>
+            <a:ext cx="3657600" cy="292608"/>
           </a:xfrm>
           <a:prstGeom prst="roundRect">
             <a:avLst/>
@@ -27706,8 +27706,8 @@
         </p:nvSpPr>
         <p:spPr>
           <a:xfrm>
-            <a:off x="8915400" y="6446520"/>
-            <a:ext cx="2514600" cy="256032"/>
+            <a:off x="7726679" y="6455664"/>
+            <a:ext cx="3657600" cy="237744"/>
           </a:xfrm>
           <a:prstGeom prst="rect">
             <a:avLst/>
@@ -27728,7 +27728,7 @@
                 </a:solidFill>
                 <a:latin typeface="Arial"/>
               </a:rPr>
-              <a:t>CORUM DECIDES  ·  C&amp;W DELIVERS</a:t>
+              <a:t>CORUM DECIDES  ·  C&amp;W DELIVERS  ·  PwC ALIGNED</a:t>
             </a:r>
           </a:p>
         </p:txBody>
@@ -28701,7 +28701,7 @@
         <p:spPr>
           <a:xfrm>
             <a:off x="640080" y="5669280"/>
-            <a:ext cx="4023360" cy="457200"/>
+            <a:ext cx="5943600" cy="457200"/>
           </a:xfrm>
           <a:prstGeom prst="roundRect">
             <a:avLst/>
@@ -28744,8 +28744,8 @@
         </p:nvSpPr>
         <p:spPr>
           <a:xfrm>
-            <a:off x="640080" y="5742432"/>
-            <a:ext cx="4023360" cy="320040"/>
+            <a:off x="640080" y="5751576"/>
+            <a:ext cx="5943600" cy="320040"/>
           </a:xfrm>
           <a:prstGeom prst="rect">
             <a:avLst/>
@@ -28766,7 +28766,7 @@
                 </a:solidFill>
                 <a:latin typeface="Arial"/>
               </a:rPr>
-              <a:t>CORUM DECIDES  ·  C&amp;W DELIVERS</a:t>
+              <a:t>CORUM DECIDES  ·  C&amp;W DELIVERS  ·  PwC ALIGNED</a:t>
             </a:r>
           </a:p>
         </p:txBody>
@@ -28981,8 +28981,8 @@
         </p:nvSpPr>
         <p:spPr>
           <a:xfrm>
-            <a:off x="8915400" y="6419088"/>
-            <a:ext cx="2514600" cy="292608"/>
+            <a:off x="7726679" y="6419088"/>
+            <a:ext cx="3657600" cy="292608"/>
           </a:xfrm>
           <a:prstGeom prst="roundRect">
             <a:avLst/>
@@ -29025,8 +29025,8 @@
         </p:nvSpPr>
         <p:spPr>
           <a:xfrm>
-            <a:off x="8915400" y="6446520"/>
-            <a:ext cx="2514600" cy="256032"/>
+            <a:off x="7726679" y="6455664"/>
+            <a:ext cx="3657600" cy="237744"/>
           </a:xfrm>
           <a:prstGeom prst="rect">
             <a:avLst/>
@@ -29047,7 +29047,7 @@
                 </a:solidFill>
                 <a:latin typeface="Arial"/>
               </a:rPr>
-              <a:t>CORUM DECIDES  ·  C&amp;W DELIVERS</a:t>
+              <a:t>CORUM DECIDES  ·  C&amp;W DELIVERS  ·  PwC ALIGNED</a:t>
             </a:r>
           </a:p>
         </p:txBody>
@@ -30038,8 +30038,8 @@
         </p:nvSpPr>
         <p:spPr>
           <a:xfrm>
-            <a:off x="8915400" y="6419088"/>
-            <a:ext cx="2514600" cy="292608"/>
+            <a:off x="7726679" y="6419088"/>
+            <a:ext cx="3657600" cy="292608"/>
           </a:xfrm>
           <a:prstGeom prst="roundRect">
             <a:avLst/>
@@ -30082,8 +30082,8 @@
         </p:nvSpPr>
         <p:spPr>
           <a:xfrm>
-            <a:off x="8915400" y="6446520"/>
-            <a:ext cx="2514600" cy="256032"/>
+            <a:off x="7726679" y="6455664"/>
+            <a:ext cx="3657600" cy="237744"/>
           </a:xfrm>
           <a:prstGeom prst="rect">
             <a:avLst/>
@@ -30104,7 +30104,7 @@
                 </a:solidFill>
                 <a:latin typeface="Arial"/>
               </a:rPr>
-              <a:t>CORUM DECIDES  ·  C&amp;W DELIVERS</a:t>
+              <a:t>CORUM DECIDES  ·  C&amp;W DELIVERS  ·  PwC ALIGNED</a:t>
             </a:r>
           </a:p>
         </p:txBody>
@@ -31243,8 +31243,8 @@
         </p:nvSpPr>
         <p:spPr>
           <a:xfrm>
-            <a:off x="8915400" y="6419088"/>
-            <a:ext cx="2514600" cy="292608"/>
+            <a:off x="7726679" y="6419088"/>
+            <a:ext cx="3657600" cy="292608"/>
           </a:xfrm>
           <a:prstGeom prst="roundRect">
             <a:avLst/>
@@ -31287,8 +31287,8 @@
         </p:nvSpPr>
         <p:spPr>
           <a:xfrm>
-            <a:off x="8915400" y="6446520"/>
-            <a:ext cx="2514600" cy="256032"/>
+            <a:off x="7726679" y="6455664"/>
+            <a:ext cx="3657600" cy="237744"/>
           </a:xfrm>
           <a:prstGeom prst="rect">
             <a:avLst/>
@@ -31309,7 +31309,7 @@
                 </a:solidFill>
                 <a:latin typeface="Arial"/>
               </a:rPr>
-              <a:t>CORUM DECIDES  ·  C&amp;W DELIVERS</a:t>
+              <a:t>CORUM DECIDES  ·  C&amp;W DELIVERS  ·  PwC ALIGNED</a:t>
             </a:r>
           </a:p>
         </p:txBody>

</xml_diff>

<commit_message>
Corum pitch: finale QA + herbruikbaar maken
- golden-thread chip regel gelijkgetrokken (deck + alle 3 prompts): op elke content-slide behalve cover, teampagina, slotslide
- prompt-3 interne tegenspraak (slide 6/DO-NOT) opgelost; slide-aantal overal 24
- README.md toegevoegd (3-prompt workflow + herbruik-checklist)
- TEMPLATE-prompts-reusable.md toegevoegd (3 prompts met {{variabelen}} voor elke pitch)
- v1-restanten verwijderd (build_wireframe.py, claude-design-prompt.md)

Co-Authored-By: Claude Opus 4.8 <noreply@anthropic.com>
Claude-Session: https://claude.ai/code/session_01Ve1ndCHgviaGx4xoosLGch
</commit_message>
<xml_diff>
--- a/corum-pitch/Corum-Westgate-I-Pitch-Wireframe.pptx
+++ b/corum-pitch/Corum-Westgate-I-Pitch-Wireframe.pptx
@@ -25400,7 +25400,86 @@
       </p:sp>
       <p:sp>
         <p:nvSpPr>
-          <p:cNvPr id="7" name="Rectangle 6"/>
+          <p:cNvPr id="7" name="Rounded Rectangle 6"/>
+          <p:cNvSpPr/>
+          <p:nvPr/>
+        </p:nvSpPr>
+        <p:spPr>
+          <a:xfrm>
+            <a:off x="7726679" y="6419088"/>
+            <a:ext cx="3657600" cy="292608"/>
+          </a:xfrm>
+          <a:prstGeom prst="roundRect">
+            <a:avLst/>
+          </a:prstGeom>
+          <a:solidFill>
+            <a:srgbClr val="C3002B"/>
+          </a:solidFill>
+          <a:ln>
+            <a:noFill/>
+          </a:ln>
+          <a:effectLst/>
+        </p:spPr>
+        <p:style>
+          <a:lnRef idx="1">
+            <a:schemeClr val="accent1"/>
+          </a:lnRef>
+          <a:fillRef idx="3">
+            <a:schemeClr val="accent1"/>
+          </a:fillRef>
+          <a:effectRef idx="2">
+            <a:schemeClr val="accent1"/>
+          </a:effectRef>
+          <a:fontRef idx="minor">
+            <a:schemeClr val="lt1"/>
+          </a:fontRef>
+        </p:style>
+        <p:txBody>
+          <a:bodyPr rtlCol="0" anchor="ctr"/>
+          <a:lstStyle/>
+          <a:p>
+            <a:pPr algn="ctr"/>
+          </a:p>
+        </p:txBody>
+      </p:sp>
+      <p:sp>
+        <p:nvSpPr>
+          <p:cNvPr id="8" name="TextBox 7"/>
+          <p:cNvSpPr txBox="1"/>
+          <p:nvPr/>
+        </p:nvSpPr>
+        <p:spPr>
+          <a:xfrm>
+            <a:off x="7726679" y="6455664"/>
+            <a:ext cx="3657600" cy="237744"/>
+          </a:xfrm>
+          <a:prstGeom prst="rect">
+            <a:avLst/>
+          </a:prstGeom>
+          <a:noFill/>
+        </p:spPr>
+        <p:txBody>
+          <a:bodyPr wrap="square" anchor="t">
+            <a:spAutoFit/>
+          </a:bodyPr>
+          <a:lstStyle/>
+          <a:p>
+            <a:pPr algn="ctr"/>
+            <a:r>
+              <a:rPr sz="800" b="1" i="0">
+                <a:solidFill>
+                  <a:srgbClr val="FFFFFF"/>
+                </a:solidFill>
+                <a:latin typeface="Arial"/>
+              </a:rPr>
+              <a:t>CORUM DECIDES  ·  C&amp;W DELIVERS  ·  PwC ALIGNED</a:t>
+            </a:r>
+          </a:p>
+        </p:txBody>
+      </p:sp>
+      <p:sp>
+        <p:nvSpPr>
+          <p:cNvPr id="9" name="Rectangle 8"/>
           <p:cNvSpPr/>
           <p:nvPr/>
         </p:nvSpPr>
@@ -25447,7 +25526,7 @@
       </p:sp>
       <p:sp>
         <p:nvSpPr>
-          <p:cNvPr id="8" name="TextBox 7"/>
+          <p:cNvPr id="10" name="TextBox 9"/>
           <p:cNvSpPr txBox="1"/>
           <p:nvPr/>
         </p:nvSpPr>
@@ -25482,7 +25561,7 @@
       </p:sp>
       <p:sp>
         <p:nvSpPr>
-          <p:cNvPr id="9" name="TextBox 8"/>
+          <p:cNvPr id="11" name="TextBox 10"/>
           <p:cNvSpPr txBox="1"/>
           <p:nvPr/>
         </p:nvSpPr>
@@ -25517,7 +25596,7 @@
       </p:sp>
       <p:sp>
         <p:nvSpPr>
-          <p:cNvPr id="10" name="TextBox 9"/>
+          <p:cNvPr id="12" name="TextBox 11"/>
           <p:cNvSpPr txBox="1"/>
           <p:nvPr/>
         </p:nvSpPr>
@@ -25564,7 +25643,7 @@
       </p:sp>
       <p:sp>
         <p:nvSpPr>
-          <p:cNvPr id="11" name="Rectangle 10"/>
+          <p:cNvPr id="13" name="Rectangle 12"/>
           <p:cNvSpPr/>
           <p:nvPr/>
         </p:nvSpPr>
@@ -25611,7 +25690,7 @@
       </p:sp>
       <p:sp>
         <p:nvSpPr>
-          <p:cNvPr id="12" name="TextBox 11"/>
+          <p:cNvPr id="14" name="TextBox 13"/>
           <p:cNvSpPr txBox="1"/>
           <p:nvPr/>
         </p:nvSpPr>
@@ -25646,7 +25725,7 @@
       </p:sp>
       <p:sp>
         <p:nvSpPr>
-          <p:cNvPr id="13" name="TextBox 12"/>
+          <p:cNvPr id="15" name="TextBox 14"/>
           <p:cNvSpPr txBox="1"/>
           <p:nvPr/>
         </p:nvSpPr>
@@ -25693,7 +25772,7 @@
       </p:sp>
       <p:sp>
         <p:nvSpPr>
-          <p:cNvPr id="14" name="TextBox 13"/>
+          <p:cNvPr id="16" name="TextBox 15"/>
           <p:cNvSpPr txBox="1"/>
           <p:nvPr/>
         </p:nvSpPr>
@@ -25740,7 +25819,7 @@
       </p:sp>
       <p:sp>
         <p:nvSpPr>
-          <p:cNvPr id="15" name="Rectangle 14"/>
+          <p:cNvPr id="17" name="Rectangle 16"/>
           <p:cNvSpPr/>
           <p:nvPr/>
         </p:nvSpPr>
@@ -25787,7 +25866,7 @@
       </p:sp>
       <p:sp>
         <p:nvSpPr>
-          <p:cNvPr id="16" name="TextBox 15"/>
+          <p:cNvPr id="18" name="TextBox 17"/>
           <p:cNvSpPr txBox="1"/>
           <p:nvPr/>
         </p:nvSpPr>
@@ -25822,7 +25901,7 @@
       </p:sp>
       <p:sp>
         <p:nvSpPr>
-          <p:cNvPr id="17" name="TextBox 16"/>
+          <p:cNvPr id="19" name="TextBox 18"/>
           <p:cNvSpPr txBox="1"/>
           <p:nvPr/>
         </p:nvSpPr>
@@ -25857,7 +25936,7 @@
       </p:sp>
       <p:sp>
         <p:nvSpPr>
-          <p:cNvPr id="18" name="TextBox 17"/>
+          <p:cNvPr id="20" name="TextBox 19"/>
           <p:cNvSpPr txBox="1"/>
           <p:nvPr/>
         </p:nvSpPr>
@@ -25904,7 +25983,7 @@
       </p:sp>
       <p:sp>
         <p:nvSpPr>
-          <p:cNvPr id="19" name="Rectangle 18"/>
+          <p:cNvPr id="21" name="Rectangle 20"/>
           <p:cNvSpPr/>
           <p:nvPr/>
         </p:nvSpPr>
@@ -25951,7 +26030,7 @@
       </p:sp>
       <p:sp>
         <p:nvSpPr>
-          <p:cNvPr id="20" name="TextBox 19"/>
+          <p:cNvPr id="22" name="TextBox 21"/>
           <p:cNvSpPr txBox="1"/>
           <p:nvPr/>
         </p:nvSpPr>
@@ -25986,7 +26065,7 @@
       </p:sp>
       <p:sp>
         <p:nvSpPr>
-          <p:cNvPr id="21" name="TextBox 20"/>
+          <p:cNvPr id="23" name="TextBox 22"/>
           <p:cNvSpPr txBox="1"/>
           <p:nvPr/>
         </p:nvSpPr>
@@ -26033,7 +26112,7 @@
       </p:sp>
       <p:sp>
         <p:nvSpPr>
-          <p:cNvPr id="22" name="TextBox 21"/>
+          <p:cNvPr id="24" name="TextBox 23"/>
           <p:cNvSpPr txBox="1"/>
           <p:nvPr/>
         </p:nvSpPr>
@@ -26080,7 +26159,7 @@
       </p:sp>
       <p:sp>
         <p:nvSpPr>
-          <p:cNvPr id="23" name="Rectangle 22"/>
+          <p:cNvPr id="25" name="Rectangle 24"/>
           <p:cNvSpPr/>
           <p:nvPr/>
         </p:nvSpPr>
@@ -26127,7 +26206,7 @@
       </p:sp>
       <p:sp>
         <p:nvSpPr>
-          <p:cNvPr id="24" name="TextBox 23"/>
+          <p:cNvPr id="26" name="TextBox 25"/>
           <p:cNvSpPr txBox="1"/>
           <p:nvPr/>
         </p:nvSpPr>
@@ -26162,7 +26241,7 @@
       </p:sp>
       <p:sp>
         <p:nvSpPr>
-          <p:cNvPr id="25" name="TextBox 24"/>
+          <p:cNvPr id="27" name="TextBox 26"/>
           <p:cNvSpPr txBox="1"/>
           <p:nvPr/>
         </p:nvSpPr>
@@ -26209,7 +26288,7 @@
       </p:sp>
       <p:sp>
         <p:nvSpPr>
-          <p:cNvPr id="26" name="TextBox 25"/>
+          <p:cNvPr id="28" name="TextBox 27"/>
           <p:cNvSpPr txBox="1"/>
           <p:nvPr/>
         </p:nvSpPr>
@@ -26256,7 +26335,7 @@
       </p:sp>
       <p:sp>
         <p:nvSpPr>
-          <p:cNvPr id="27" name="Rectangle 26"/>
+          <p:cNvPr id="29" name="Rectangle 28"/>
           <p:cNvSpPr/>
           <p:nvPr/>
         </p:nvSpPr>
@@ -26303,7 +26382,7 @@
       </p:sp>
       <p:sp>
         <p:nvSpPr>
-          <p:cNvPr id="28" name="TextBox 27"/>
+          <p:cNvPr id="30" name="TextBox 29"/>
           <p:cNvSpPr txBox="1"/>
           <p:nvPr/>
         </p:nvSpPr>
@@ -26338,7 +26417,7 @@
       </p:sp>
       <p:sp>
         <p:nvSpPr>
-          <p:cNvPr id="29" name="TextBox 28"/>
+          <p:cNvPr id="31" name="TextBox 30"/>
           <p:cNvSpPr txBox="1"/>
           <p:nvPr/>
         </p:nvSpPr>
@@ -26385,7 +26464,7 @@
       </p:sp>
       <p:sp>
         <p:nvSpPr>
-          <p:cNvPr id="30" name="TextBox 29"/>
+          <p:cNvPr id="32" name="TextBox 31"/>
           <p:cNvSpPr txBox="1"/>
           <p:nvPr/>
         </p:nvSpPr>

</xml_diff>

<commit_message>
Corum pitch: rate card slide 23 gevuld met actuele 2026 C&W PDS-tarieven (uit eigen offertes)
Co-Authored-By: Claude Opus 4.8 <noreply@anthropic.com>
Claude-Session: https://claude.ai/code/session_01Ve1ndCHgviaGx4xoosLGch
</commit_message>
<xml_diff>
--- a/corum-pitch/Corum-Westgate-I-Pitch-Wireframe.pptx
+++ b/corum-pitch/Corum-Westgate-I-Pitch-Wireframe.pptx
@@ -23819,7 +23819,7 @@
                 </a:solidFill>
                 <a:latin typeface="Arial"/>
               </a:rPr>
-              <a:t>RATE CARD (REFERENCE)</a:t>
+              <a:t>RATE CARD — C&amp;W PDS 2026</a:t>
             </a:r>
           </a:p>
         </p:txBody>
@@ -23858,7 +23858,7 @@
                 </a:solidFill>
                 <a:latin typeface="Arial"/>
               </a:rPr>
-              <a:t>Senior Project Manager   € 145 / hr</a:t>
+              <a:t>Project Manager             € 145 / hr</a:t>
             </a:r>
           </a:p>
           <a:p>
@@ -23874,7 +23874,7 @@
                 </a:solidFill>
                 <a:latin typeface="Arial"/>
               </a:rPr>
-              <a:t>Project Manager             € 135 / hr</a:t>
+              <a:t>Senior Project Manager   € 155 / hr</a:t>
             </a:r>
           </a:p>
           <a:p>
@@ -23890,7 +23890,7 @@
                 </a:solidFill>
                 <a:latin typeface="Arial"/>
               </a:rPr>
-              <a:t>Technical PM                 € 135 / hr</a:t>
+              <a:t>Cost Manager                € 145 / hr</a:t>
             </a:r>
           </a:p>
           <a:p>
@@ -23906,7 +23906,7 @@
                 </a:solidFill>
                 <a:latin typeface="Arial"/>
               </a:rPr>
-              <a:t>Cost Manager                € 125 / hr</a:t>
+              <a:t>Associate Director          € 175 / hr</a:t>
             </a:r>
           </a:p>
           <a:p>
@@ -23922,7 +23922,7 @@
                 </a:solidFill>
                 <a:latin typeface="Arial"/>
               </a:rPr>
-              <a:t>Site Manager                 € 120 / hr</a:t>
+              <a:t>Partner                          € 250 / hr</a:t>
             </a:r>
           </a:p>
           <a:p>
@@ -23954,7 +23954,7 @@
                 </a:solidFill>
                 <a:latin typeface="Arial"/>
               </a:rPr>
-              <a:t>[ tarieven &amp; inzet definitief met Frank ]</a:t>
+              <a:t>[ tarieven excl. btw · inzet definitief met Frank ]</a:t>
             </a:r>
           </a:p>
         </p:txBody>

</xml_diff>

<commit_message>
Corum pitch: Prompt 2 - wireframe geregenereerd conform definitieve Fabel-spec (action titles slide 5/8/11/14 afgestemd)
Co-Authored-By: Claude Opus 4.8 <noreply@anthropic.com>
Claude-Session: https://claude.ai/code/session_01Ve1ndCHgviaGx4xoosLGch
</commit_message>
<xml_diff>
--- a/corum-pitch/Corum-Westgate-I-Pitch-Wireframe.pptx
+++ b/corum-pitch/Corum-Westgate-I-Pitch-Wireframe.pptx
@@ -4347,7 +4347,7 @@
                 </a:solidFill>
                 <a:latin typeface="Arial"/>
               </a:rPr>
-              <a:t>We organize the sustainability works — from M3E's design</a:t>
+              <a:t>We organize the works — from M3E's design</a:t>
             </a:r>
           </a:p>
           <a:p>
@@ -7728,7 +7728,7 @@
                 </a:solidFill>
                 <a:latin typeface="Arial"/>
               </a:rPr>
-              <a:t>You commit in steps: start small, then scale with confidence</a:t>
+              <a:t>You commit in steps: start small, scale with confidence</a:t>
             </a:r>
           </a:p>
         </p:txBody>
@@ -27646,7 +27646,7 @@
                 </a:solidFill>
                 <a:latin typeface="Arial"/>
               </a:rPr>
-              <a:t>Three forces threaten the asset — and they all converge</a:t>
+              <a:t>Three forces converge on one occupied building —</a:t>
             </a:r>
           </a:p>
           <a:p>
@@ -27658,7 +27658,7 @@
                 </a:solidFill>
                 <a:latin typeface="Arial"/>
               </a:rPr>
-              <a:t>on one building, still in use</a:t>
+              <a:t>and all three touch your return</a:t>
             </a:r>
           </a:p>
         </p:txBody>
@@ -30022,7 +30022,7 @@
                 </a:solidFill>
                 <a:latin typeface="Arial"/>
               </a:rPr>
-              <a:t>You already sit at the centre of four parties — we become</a:t>
+              <a:t>Four parties, one hub: we connect Corum, PwC,</a:t>
             </a:r>
           </a:p>
           <a:p>
@@ -30034,7 +30034,7 @@
                 </a:solidFill>
                 <a:latin typeface="Arial"/>
               </a:rPr>
-              <a:t>the hub that connects them</a:t>
+              <a:t>M3E and the contractor</a:t>
             </a:r>
           </a:p>
         </p:txBody>

</xml_diff>